<commit_message>
Samples: remove time references, measured speech bubbles, CTA slide
- No specific times on slides (they're per-team settings)
- Speech bubbles sized from measured text with fixed padding; tails anchored
  to Bod Annan's head/eye line per pose
- CTA: bodstudio.com, sales line, email, social, powered by Bod Studio

Co-Authored-By: Claude Opus 5.5 <noreply@anthropic.com>
Claude-Session: https://claude.ai/code/session_01GrK1EgoeNeSZw9mqcLcVqN
</commit_message>
<xml_diff>
--- a/bod-app-sales-deck/samples/Bod-App-Sample-Slides.pptx
+++ b/bod-app-sales-deck/samples/Bod-App-Sample-Slides.pptx
@@ -8,9 +8,10 @@
     <p:sldId id="256" r:id="rId2"/>
     <p:sldId id="257" r:id="rId3"/>
     <p:sldId id="258" r:id="rId4"/>
+    <p:sldId id="259" r:id="rId5"/>
   </p:sldIdLst>
   <p:notesMasterIdLst>
-    <p:notesMasterId r:id="rId5"/>
+    <p:notesMasterId r:id="rId6"/>
   </p:notesMasterIdLst>
   <p:sldSz cx="12192000" cy="6858000"/>
   <p:notesSz cx="6858000" cy="12192000"/>
@@ -592,7 +593,7 @@
           <a:p>
             <a:r>
               <a:rPr lang="en-US" dirty="0"/>
-              <a:t>This is the follow-up nudge. It appears once a task has waited on a client for two days.</a:t>
+              <a:t>The follow-up nudge appears when a task has been waiting on a client. Each team sets how long that is.</a:t>
             </a:r>
             <a:endParaRPr lang="en-US" dirty="0"/>
           </a:p>
@@ -680,7 +681,7 @@
           <a:p>
             <a:r>
               <a:rPr lang="en-US" dirty="0"/>
-              <a:t>Usually: briefs arrive on WhatsApp at 11 pm, nobody knows who owns what, status lives in people's heads, the client goes quiet for three days, and finished work sits unbilled. With Bod App each of those steps is handled.</a:t>
+              <a:t>Usually: briefs arrive on WhatsApp late at night, nobody knows who owns what, status lives in people's heads, the client goes quiet, and finished work sits unbilled. With Bod App each of those steps is handled.</a:t>
             </a:r>
             <a:endParaRPr lang="en-US" dirty="0"/>
           </a:p>
@@ -704,6 +705,94 @@
             <a:fld id="{F7021451-1387-4CA6-816F-3879F97B5CBC}" type="slidenum">
               <a:rPr lang="en-US"/>
               <a:t>3</a:t>
+            </a:fld>
+            <a:endParaRPr lang="en-US"/>
+          </a:p>
+        </p:txBody>
+      </p:sp>
+    </p:spTree>
+    <p:extLst>
+      <p:ext uri="{BB962C8B-B14F-4D97-AF65-F5344CB8AC3E}">
+        <p14:creationId xmlns:p14="http://schemas.microsoft.com/office/powerpoint/2010/main" val="1024086991"/>
+      </p:ext>
+    </p:extLst>
+  </p:cSld>
+  <p:clrMapOvr>
+    <a:masterClrMapping/>
+  </p:clrMapOvr>
+</p:notes>
+</file>
+
+<file path=ppt/notesSlides/notesSlide4.xml><?xml version="1.0" encoding="utf-8"?>
+<p:notes xmlns:a="http://schemas.openxmlformats.org/drawingml/2006/main" xmlns:r="http://schemas.openxmlformats.org/officeDocument/2006/relationships" xmlns:p="http://schemas.openxmlformats.org/presentationml/2006/main">
+  <p:cSld>
+    <p:spTree>
+      <p:nvGrpSpPr>
+        <p:cNvPr id="1" name=""/>
+        <p:cNvGrpSpPr/>
+        <p:nvPr/>
+      </p:nvGrpSpPr>
+      <p:grpSpPr>
+        <a:xfrm>
+          <a:off x="0" y="0"/>
+          <a:ext cx="0" cy="0"/>
+          <a:chOff x="0" y="0"/>
+          <a:chExt cx="0" cy="0"/>
+        </a:xfrm>
+      </p:grpSpPr>
+      <p:sp>
+        <p:nvSpPr>
+          <p:cNvPr id="2" name="Slide Image Placeholder 1"/>
+          <p:cNvSpPr>
+            <a:spLocks noGrp="1" noRot="1" noChangeAspect="1"/>
+          </p:cNvSpPr>
+          <p:nvPr>
+            <p:ph type="sldImg"/>
+          </p:nvPr>
+        </p:nvSpPr>
+        <p:spPr/>
+      </p:sp>
+      <p:sp>
+        <p:nvSpPr>
+          <p:cNvPr id="3" name="Notes Placeholder 2"/>
+          <p:cNvSpPr>
+            <a:spLocks noGrp="1"/>
+          </p:cNvSpPr>
+          <p:nvPr>
+            <p:ph type="body" idx="1"/>
+          </p:nvPr>
+        </p:nvSpPr>
+        <p:spPr/>
+        <p:txBody>
+          <a:bodyPr/>
+          <a:lstStyle/>
+          <a:p>
+            <a:r>
+              <a:rPr lang="en-US" dirty="0"/>
+              <a:t>Close by offering the walkthrough, not the sale.</a:t>
+            </a:r>
+            <a:endParaRPr lang="en-US" dirty="0"/>
+          </a:p>
+        </p:txBody>
+      </p:sp>
+      <p:sp>
+        <p:nvSpPr>
+          <p:cNvPr id="4" name="Slide Number Placeholder 3"/>
+          <p:cNvSpPr>
+            <a:spLocks noGrp="1"/>
+          </p:cNvSpPr>
+          <p:nvPr>
+            <p:ph type="sldNum" sz="quarter" idx="10"/>
+          </p:nvPr>
+        </p:nvSpPr>
+        <p:spPr/>
+        <p:txBody>
+          <a:bodyPr/>
+          <a:lstStyle/>
+          <a:p>
+            <a:fld id="{F7021451-1387-4CA6-816F-3879F97B5CBC}" type="slidenum">
+              <a:rPr lang="en-US"/>
+              <a:t>4</a:t>
             </a:fld>
             <a:endParaRPr lang="en-US"/>
           </a:p>
@@ -1293,7 +1382,7 @@
                 <a:ea typeface="Plus Jakarta Sans" pitchFamily="34" charset="-122"/>
                 <a:cs typeface="Plus Jakarta Sans" pitchFamily="34" charset="-120"/>
               </a:rPr>
-              <a:t>MYBODSTUDIO.COM</a:t>
+              <a:t>BODSTUDIO.COM</a:t>
             </a:r>
             <a:endParaRPr lang="en-US" sz="1000" dirty="0"/>
           </a:p>
@@ -1355,12 +1444,12 @@
         </p:nvSpPr>
         <p:spPr>
           <a:xfrm>
-            <a:off x="6998854" y="2788920"/>
-            <a:ext cx="2377440" cy="713232"/>
+            <a:off x="7159841" y="2793291"/>
+            <a:ext cx="2167235" cy="795528"/>
           </a:xfrm>
           <a:prstGeom prst="roundRect">
             <a:avLst>
-              <a:gd name="adj" fmla="val 25641"/>
+              <a:gd name="adj" fmla="val 20690"/>
             </a:avLst>
           </a:prstGeom>
           <a:solidFill>
@@ -1377,8 +1466,8 @@
         </p:nvSpPr>
         <p:spPr>
           <a:xfrm rot="10800000">
-            <a:off x="7638934" y="3493008"/>
-            <a:ext cx="219456" cy="175565"/>
+            <a:off x="7474416" y="3579675"/>
+            <a:ext cx="237744" cy="182880"/>
           </a:xfrm>
           <a:prstGeom prst="triangle">
             <a:avLst/>
@@ -1397,8 +1486,8 @@
         </p:nvSpPr>
         <p:spPr>
           <a:xfrm>
-            <a:off x="7227454" y="2788920"/>
-            <a:ext cx="1920240" cy="713232"/>
+            <a:off x="7397585" y="2957883"/>
+            <a:ext cx="1691747" cy="466344"/>
           </a:xfrm>
           <a:prstGeom prst="rect">
             <a:avLst/>
@@ -1412,7 +1501,7 @@
           <a:p>
             <a:pPr indent="0" marL="0">
               <a:lnSpc>
-                <a:spcPct val="110000"/>
+                <a:spcPts val="1840"/>
               </a:lnSpc>
               <a:buNone/>
             </a:pPr>
@@ -1425,7 +1514,27 @@
                 <a:ea typeface="Manrope" pitchFamily="34" charset="-122"/>
                 <a:cs typeface="Manrope" pitchFamily="34" charset="-120"/>
               </a:rPr>
-              <a:t>Come in. Let me show you around.</a:t>
+              <a:t>Come in. Let me</a:t>
+            </a:r>
+            <a:endParaRPr lang="en-US" sz="1500" dirty="0"/>
+          </a:p>
+          <a:p>
+            <a:pPr indent="0" marL="0">
+              <a:lnSpc>
+                <a:spcPts val="1840"/>
+              </a:lnSpc>
+              <a:buNone/>
+            </a:pPr>
+            <a:r>
+              <a:rPr lang="en-US" sz="1500" b="1" dirty="0">
+                <a:solidFill>
+                  <a:srgbClr val="0B0D0C"/>
+                </a:solidFill>
+                <a:latin typeface="Manrope" pitchFamily="34" charset="0"/>
+                <a:ea typeface="Manrope" pitchFamily="34" charset="-122"/>
+                <a:cs typeface="Manrope" pitchFamily="34" charset="-120"/>
+              </a:rPr>
+              <a:t>show you around.</a:t>
             </a:r>
             <a:endParaRPr lang="en-US" sz="1500" dirty="0"/>
           </a:p>
@@ -1520,7 +1629,7 @@
                 <a:ea typeface="Plus Jakarta Sans" pitchFamily="34" charset="-122"/>
                 <a:cs typeface="Plus Jakarta Sans" pitchFamily="34" charset="-120"/>
               </a:rPr>
-              <a:t>3 PM</a:t>
+              <a:t>FOLLOW-UPS</a:t>
             </a:r>
             <a:endParaRPr lang="en-US" sz="1000" dirty="0"/>
           </a:p>
@@ -1596,7 +1705,7 @@
         </p:nvSpPr>
         <p:spPr>
           <a:xfrm>
-            <a:off x="685800" y="2560320"/>
+            <a:off x="685800" y="2468880"/>
             <a:ext cx="4375023" cy="777240"/>
           </a:xfrm>
           <a:prstGeom prst="rect">
@@ -1624,7 +1733,7 @@
                 <a:ea typeface="Manrope" pitchFamily="34" charset="-122"/>
                 <a:cs typeface="Manrope" pitchFamily="34" charset="-120"/>
               </a:rPr>
-              <a:t>After two days of waiting, Bod App drafts the follow-up. You just send it.</a:t>
+              <a:t>Bod App notices, and drafts the follow-up for you. You just send it.</a:t>
             </a:r>
             <a:endParaRPr lang="en-US" sz="1800" dirty="0"/>
           </a:p>
@@ -1646,8 +1755,8 @@
         </p:blipFill>
         <p:spPr>
           <a:xfrm>
-            <a:off x="548640" y="3931920"/>
-            <a:ext cx="2225942" cy="2240280"/>
+            <a:off x="594360" y="4434840"/>
+            <a:ext cx="1726241" cy="1737360"/>
           </a:xfrm>
           <a:prstGeom prst="rect">
             <a:avLst/>
@@ -1662,12 +1771,12 @@
         </p:nvSpPr>
         <p:spPr>
           <a:xfrm>
-            <a:off x="3094622" y="4251960"/>
-            <a:ext cx="2514600" cy="777240"/>
+            <a:off x="368752" y="3456121"/>
+            <a:ext cx="2814816" cy="795528"/>
           </a:xfrm>
           <a:prstGeom prst="roundRect">
             <a:avLst>
-              <a:gd name="adj" fmla="val 23529"/>
+              <a:gd name="adj" fmla="val 20690"/>
             </a:avLst>
           </a:prstGeom>
           <a:solidFill>
@@ -1683,9 +1792,9 @@
           <p:nvPr/>
         </p:nvSpPr>
         <p:spPr>
-          <a:xfrm rot="16200000">
-            <a:off x="2928201" y="4530852"/>
-            <a:ext cx="219456" cy="175565"/>
+          <a:xfrm rot="10800000">
+            <a:off x="1150621" y="4242505"/>
+            <a:ext cx="237744" cy="182880"/>
           </a:xfrm>
           <a:prstGeom prst="triangle">
             <a:avLst/>
@@ -1704,8 +1813,8 @@
         </p:nvSpPr>
         <p:spPr>
           <a:xfrm>
-            <a:off x="3323222" y="4251960"/>
-            <a:ext cx="2057400" cy="777240"/>
+            <a:off x="606496" y="3620713"/>
+            <a:ext cx="2339328" cy="466344"/>
           </a:xfrm>
           <a:prstGeom prst="rect">
             <a:avLst/>
@@ -1719,7 +1828,7 @@
           <a:p>
             <a:pPr indent="0" marL="0">
               <a:lnSpc>
-                <a:spcPct val="110000"/>
+                <a:spcPts val="1840"/>
               </a:lnSpc>
               <a:buNone/>
             </a:pPr>
@@ -1732,7 +1841,27 @@
                 <a:ea typeface="Manrope" pitchFamily="34" charset="-122"/>
                 <a:cs typeface="Manrope" pitchFamily="34" charset="-120"/>
               </a:rPr>
-              <a:t>Two days, no reply. I've written it for you.</a:t>
+              <a:t>No reply yet? I've written</a:t>
+            </a:r>
+            <a:endParaRPr lang="en-US" sz="1500" dirty="0"/>
+          </a:p>
+          <a:p>
+            <a:pPr indent="0" marL="0">
+              <a:lnSpc>
+                <a:spcPts val="1840"/>
+              </a:lnSpc>
+              <a:buNone/>
+            </a:pPr>
+            <a:r>
+              <a:rPr lang="en-US" sz="1500" b="1" dirty="0">
+                <a:solidFill>
+                  <a:srgbClr val="0B0D0C"/>
+                </a:solidFill>
+                <a:latin typeface="Manrope" pitchFamily="34" charset="0"/>
+                <a:ea typeface="Manrope" pitchFamily="34" charset="-122"/>
+                <a:cs typeface="Manrope" pitchFamily="34" charset="-120"/>
+              </a:rPr>
+              <a:t>the follow-up for you.</a:t>
             </a:r>
             <a:endParaRPr lang="en-US" sz="1500" dirty="0"/>
           </a:p>
@@ -2757,7 +2886,7 @@
                 <a:ea typeface="Manrope" pitchFamily="34" charset="-122"/>
                 <a:cs typeface="Manrope" pitchFamily="34" charset="-120"/>
               </a:rPr>
-              <a:t>Quiet for two days? It follows up.</a:t>
+              <a:t>Gone quiet? It drafts the follow-up.</a:t>
             </a:r>
             <a:endParaRPr lang="en-US" sz="1500" dirty="0"/>
           </a:p>
@@ -2951,8 +3080,8 @@
         </p:blipFill>
         <p:spPr>
           <a:xfrm>
-            <a:off x="10062670" y="594360"/>
-            <a:ext cx="1443225" cy="1737360"/>
+            <a:off x="10134419" y="548640"/>
+            <a:ext cx="1481205" cy="1783080"/>
           </a:xfrm>
           <a:prstGeom prst="rect">
             <a:avLst/>
@@ -2967,12 +3096,12 @@
         </p:nvSpPr>
         <p:spPr>
           <a:xfrm>
-            <a:off x="7273750" y="1005840"/>
-            <a:ext cx="2514600" cy="731520"/>
+            <a:off x="7580991" y="803483"/>
+            <a:ext cx="2497872" cy="795528"/>
           </a:xfrm>
           <a:prstGeom prst="roundRect">
             <a:avLst>
-              <a:gd name="adj" fmla="val 25000"/>
+              <a:gd name="adj" fmla="val 20690"/>
             </a:avLst>
           </a:prstGeom>
           <a:solidFill>
@@ -2989,8 +3118,8 @@
         </p:nvSpPr>
         <p:spPr>
           <a:xfrm rot="5400000">
-            <a:off x="9779206" y="1261872"/>
-            <a:ext cx="219456" cy="175565"/>
+            <a:off x="10042287" y="1082375"/>
+            <a:ext cx="237744" cy="182880"/>
           </a:xfrm>
           <a:prstGeom prst="triangle">
             <a:avLst/>
@@ -3009,8 +3138,8 @@
         </p:nvSpPr>
         <p:spPr>
           <a:xfrm>
-            <a:off x="7502350" y="1005840"/>
-            <a:ext cx="2057400" cy="731520"/>
+            <a:off x="7818735" y="968075"/>
+            <a:ext cx="2022384" cy="466344"/>
           </a:xfrm>
           <a:prstGeom prst="rect">
             <a:avLst/>
@@ -3024,7 +3153,7 @@
           <a:p>
             <a:pPr indent="0" marL="0">
               <a:lnSpc>
-                <a:spcPct val="110000"/>
+                <a:spcPts val="1840"/>
               </a:lnSpc>
               <a:buNone/>
             </a:pPr>
@@ -3037,7 +3166,27 @@
                 <a:ea typeface="Manrope" pitchFamily="34" charset="-122"/>
                 <a:cs typeface="Manrope" pitchFamily="34" charset="-120"/>
               </a:rPr>
-              <a:t>Every job, same path. I watch every step.</a:t>
+              <a:t>Every job, same path.</a:t>
+            </a:r>
+            <a:endParaRPr lang="en-US" sz="1500" dirty="0"/>
+          </a:p>
+          <a:p>
+            <a:pPr indent="0" marL="0">
+              <a:lnSpc>
+                <a:spcPts val="1840"/>
+              </a:lnSpc>
+              <a:buNone/>
+            </a:pPr>
+            <a:r>
+              <a:rPr lang="en-US" sz="1500" b="1" dirty="0">
+                <a:solidFill>
+                  <a:srgbClr val="0B0D0C"/>
+                </a:solidFill>
+                <a:latin typeface="Manrope" pitchFamily="34" charset="0"/>
+                <a:ea typeface="Manrope" pitchFamily="34" charset="-122"/>
+                <a:cs typeface="Manrope" pitchFamily="34" charset="-120"/>
+              </a:rPr>
+              <a:t>I watch every step.</a:t>
             </a:r>
             <a:endParaRPr lang="en-US" sz="1500" dirty="0"/>
           </a:p>
@@ -3115,9 +3264,693 @@
                 <a:ea typeface="Plus Jakarta Sans" pitchFamily="34" charset="-122"/>
                 <a:cs typeface="Plus Jakarta Sans" pitchFamily="34" charset="-120"/>
               </a:rPr>
-              <a:t>11</a:t>
+              <a:t>03</a:t>
             </a:r>
             <a:endParaRPr lang="en-US" sz="1000" dirty="0"/>
+          </a:p>
+        </p:txBody>
+      </p:sp>
+    </p:spTree>
+  </p:cSld>
+  <p:clrMapOvr>
+    <a:masterClrMapping/>
+  </p:clrMapOvr>
+</p:sld>
+</file>
+
+<file path=ppt/slides/slide4.xml><?xml version="1.0" encoding="utf-8"?>
+<p:sld xmlns:a="http://schemas.openxmlformats.org/drawingml/2006/main" xmlns:r="http://schemas.openxmlformats.org/officeDocument/2006/relationships" xmlns:p="http://schemas.openxmlformats.org/presentationml/2006/main">
+  <p:cSld name="Slide 4">
+    <p:bg>
+      <p:bgPr>
+        <a:solidFill>
+          <a:srgbClr val="0B0D0C"/>
+        </a:solidFill>
+      </p:bgPr>
+    </p:bg>
+    <p:spTree>
+      <p:nvGrpSpPr>
+        <p:cNvPr id="1" name=""/>
+        <p:cNvGrpSpPr/>
+        <p:nvPr/>
+      </p:nvGrpSpPr>
+      <p:grpSpPr>
+        <a:xfrm>
+          <a:off x="0" y="0"/>
+          <a:ext cx="0" cy="0"/>
+          <a:chOff x="0" y="0"/>
+          <a:chExt cx="0" cy="0"/>
+        </a:xfrm>
+      </p:grpSpPr>
+      <p:pic>
+        <p:nvPicPr>
+          <p:cNvPr id="2" name="Image 0" descr="/tmp/claude-0/-home-user-Claude-Works/c609e3f7-e17f-5f43-8424-4df30cb9a6a9/scratchpad/build/s/img/glow.png">    </p:cNvPr>
+          <p:cNvPicPr>
+            <a:picLocks noChangeAspect="1"/>
+          </p:cNvPicPr>
+          <p:nvPr/>
+        </p:nvPicPr>
+        <p:blipFill>
+          <a:blip r:embed="rId1"/>
+          <a:stretch>
+            <a:fillRect/>
+          </a:stretch>
+        </p:blipFill>
+        <p:spPr>
+          <a:xfrm>
+            <a:off x="6763936" y="-548640"/>
+            <a:ext cx="6936520" cy="6936520"/>
+          </a:xfrm>
+          <a:prstGeom prst="rect">
+            <a:avLst/>
+          </a:prstGeom>
+        </p:spPr>
+      </p:pic>
+      <p:sp>
+        <p:nvSpPr>
+          <p:cNvPr id="3" name="Text 0"/>
+          <p:cNvSpPr txBox="1"/>
+          <p:nvPr/>
+        </p:nvSpPr>
+        <p:spPr>
+          <a:xfrm>
+            <a:off x="685800" y="640080"/>
+            <a:ext cx="3657600" cy="201168"/>
+          </a:xfrm>
+          <a:prstGeom prst="rect">
+            <a:avLst/>
+          </a:prstGeom>
+          <a:noFill/>
+          <a:ln/>
+        </p:spPr>
+        <p:txBody>
+          <a:bodyPr wrap="square" lIns="0" tIns="0" rIns="0" bIns="0" rtlCol="0" anchor="t"/>
+          <a:lstStyle/>
+          <a:p>
+            <a:pPr indent="0" marL="0">
+              <a:buNone/>
+            </a:pPr>
+            <a:r>
+              <a:rPr lang="en-US" sz="1000" b="1" spc="200" kern="0" dirty="0">
+                <a:solidFill>
+                  <a:srgbClr val="B8E62E"/>
+                </a:solidFill>
+                <a:latin typeface="Plus Jakarta Sans" pitchFamily="34" charset="0"/>
+                <a:ea typeface="Plus Jakarta Sans" pitchFamily="34" charset="-122"/>
+                <a:cs typeface="Plus Jakarta Sans" pitchFamily="34" charset="-120"/>
+              </a:rPr>
+              <a:t>LET'S TALK</a:t>
+            </a:r>
+            <a:endParaRPr lang="en-US" sz="1000" dirty="0"/>
+          </a:p>
+        </p:txBody>
+      </p:sp>
+      <p:sp>
+        <p:nvSpPr>
+          <p:cNvPr id="4" name="Text 1"/>
+          <p:cNvSpPr txBox="1"/>
+          <p:nvPr/>
+        </p:nvSpPr>
+        <p:spPr>
+          <a:xfrm>
+            <a:off x="685800" y="1005840"/>
+            <a:ext cx="6216472" cy="1417320"/>
+          </a:xfrm>
+          <a:prstGeom prst="rect">
+            <a:avLst/>
+          </a:prstGeom>
+          <a:noFill/>
+          <a:ln/>
+        </p:spPr>
+        <p:txBody>
+          <a:bodyPr wrap="square" lIns="0" tIns="0" rIns="0" bIns="0" rtlCol="0" anchor="t"/>
+          <a:lstStyle/>
+          <a:p>
+            <a:pPr indent="0" marL="0">
+              <a:lnSpc>
+                <a:spcPct val="100000"/>
+              </a:lnSpc>
+              <a:buNone/>
+            </a:pPr>
+            <a:r>
+              <a:rPr lang="en-US" sz="4400" b="1" dirty="0">
+                <a:solidFill>
+                  <a:srgbClr val="F4F6F5"/>
+                </a:solidFill>
+                <a:latin typeface="Epilogue" pitchFamily="34" charset="0"/>
+                <a:ea typeface="Epilogue" pitchFamily="34" charset="-122"/>
+                <a:cs typeface="Epilogue" pitchFamily="34" charset="-120"/>
+              </a:rPr>
+              <a:t>Come see</a:t>
+            </a:r>
+            <a:endParaRPr lang="en-US" sz="4400" dirty="0"/>
+          </a:p>
+          <a:p>
+            <a:pPr indent="0" marL="0">
+              <a:lnSpc>
+                <a:spcPct val="100000"/>
+              </a:lnSpc>
+              <a:buNone/>
+            </a:pPr>
+            <a:r>
+              <a:rPr lang="en-US" sz="4400" b="1" dirty="0">
+                <a:solidFill>
+                  <a:srgbClr val="F4F6F5"/>
+                </a:solidFill>
+                <a:latin typeface="Epilogue" pitchFamily="34" charset="0"/>
+                <a:ea typeface="Epilogue" pitchFamily="34" charset="-122"/>
+                <a:cs typeface="Epilogue" pitchFamily="34" charset="-120"/>
+              </a:rPr>
+              <a:t>how it feels.</a:t>
+            </a:r>
+            <a:endParaRPr lang="en-US" sz="4400" dirty="0"/>
+          </a:p>
+        </p:txBody>
+      </p:sp>
+      <p:sp>
+        <p:nvSpPr>
+          <p:cNvPr id="5" name="Text 2"/>
+          <p:cNvSpPr txBox="1"/>
+          <p:nvPr/>
+        </p:nvSpPr>
+        <p:spPr>
+          <a:xfrm>
+            <a:off x="685800" y="2468880"/>
+            <a:ext cx="5295748" cy="411480"/>
+          </a:xfrm>
+          <a:prstGeom prst="rect">
+            <a:avLst/>
+          </a:prstGeom>
+          <a:noFill/>
+          <a:ln/>
+        </p:spPr>
+        <p:txBody>
+          <a:bodyPr wrap="square" lIns="0" tIns="0" rIns="0" bIns="0" rtlCol="0" anchor="t"/>
+          <a:lstStyle/>
+          <a:p>
+            <a:pPr indent="0" marL="0">
+              <a:buNone/>
+            </a:pPr>
+            <a:r>
+              <a:rPr lang="en-US" sz="1800" dirty="0">
+                <a:solidFill>
+                  <a:srgbClr val="9AA7A2"/>
+                </a:solidFill>
+                <a:latin typeface="Manrope" pitchFamily="34" charset="0"/>
+                <a:ea typeface="Manrope" pitchFamily="34" charset="-122"/>
+                <a:cs typeface="Manrope" pitchFamily="34" charset="-120"/>
+              </a:rPr>
+              <a:t>A 20-minute walkthrough on your own workflow.</a:t>
+            </a:r>
+            <a:endParaRPr lang="en-US" sz="1800" dirty="0"/>
+          </a:p>
+        </p:txBody>
+      </p:sp>
+      <p:sp>
+        <p:nvSpPr>
+          <p:cNvPr id="6" name="Text 3"/>
+          <p:cNvSpPr txBox="1"/>
+          <p:nvPr/>
+        </p:nvSpPr>
+        <p:spPr>
+          <a:xfrm>
+            <a:off x="685800" y="3429000"/>
+            <a:ext cx="5295748" cy="594360"/>
+          </a:xfrm>
+          <a:prstGeom prst="rect">
+            <a:avLst/>
+          </a:prstGeom>
+          <a:noFill/>
+          <a:ln/>
+        </p:spPr>
+        <p:txBody>
+          <a:bodyPr wrap="square" lIns="0" tIns="0" rIns="0" bIns="0" rtlCol="0" anchor="t"/>
+          <a:lstStyle/>
+          <a:p>
+            <a:pPr indent="0" marL="0">
+              <a:buNone/>
+            </a:pPr>
+            <a:r>
+              <a:rPr lang="en-US" sz="3600" b="1" dirty="0">
+                <a:solidFill>
+                  <a:srgbClr val="B8E62E"/>
+                </a:solidFill>
+                <a:latin typeface="Epilogue" pitchFamily="34" charset="0"/>
+                <a:ea typeface="Epilogue" pitchFamily="34" charset="-122"/>
+                <a:cs typeface="Epilogue" pitchFamily="34" charset="-120"/>
+              </a:rPr>
+              <a:t>bodstudio.com</a:t>
+            </a:r>
+            <a:endParaRPr lang="en-US" sz="3600" dirty="0"/>
+          </a:p>
+        </p:txBody>
+      </p:sp>
+      <p:sp>
+        <p:nvSpPr>
+          <p:cNvPr id="7" name="Text 4"/>
+          <p:cNvSpPr txBox="1"/>
+          <p:nvPr/>
+        </p:nvSpPr>
+        <p:spPr>
+          <a:xfrm>
+            <a:off x="685800" y="4306824"/>
+            <a:ext cx="1097280" cy="201168"/>
+          </a:xfrm>
+          <a:prstGeom prst="rect">
+            <a:avLst/>
+          </a:prstGeom>
+          <a:noFill/>
+          <a:ln/>
+        </p:spPr>
+        <p:txBody>
+          <a:bodyPr wrap="square" lIns="0" tIns="0" rIns="0" bIns="0" rtlCol="0" anchor="t"/>
+          <a:lstStyle/>
+          <a:p>
+            <a:pPr indent="0" marL="0">
+              <a:buNone/>
+            </a:pPr>
+            <a:r>
+              <a:rPr lang="en-US" sz="1000" b="1" spc="200" kern="0" dirty="0">
+                <a:solidFill>
+                  <a:srgbClr val="6B7773"/>
+                </a:solidFill>
+                <a:latin typeface="Plus Jakarta Sans" pitchFamily="34" charset="0"/>
+                <a:ea typeface="Plus Jakarta Sans" pitchFamily="34" charset="-122"/>
+                <a:cs typeface="Plus Jakarta Sans" pitchFamily="34" charset="-120"/>
+              </a:rPr>
+              <a:t>SALES</a:t>
+            </a:r>
+            <a:endParaRPr lang="en-US" sz="1000" dirty="0"/>
+          </a:p>
+        </p:txBody>
+      </p:sp>
+      <p:sp>
+        <p:nvSpPr>
+          <p:cNvPr id="8" name="Text 5"/>
+          <p:cNvSpPr txBox="1"/>
+          <p:nvPr/>
+        </p:nvSpPr>
+        <p:spPr>
+          <a:xfrm>
+            <a:off x="1874520" y="4251960"/>
+            <a:ext cx="4107028" cy="310896"/>
+          </a:xfrm>
+          <a:prstGeom prst="rect">
+            <a:avLst/>
+          </a:prstGeom>
+          <a:noFill/>
+          <a:ln/>
+        </p:spPr>
+        <p:txBody>
+          <a:bodyPr wrap="square" lIns="0" tIns="0" rIns="0" bIns="0" rtlCol="0" anchor="ctr"/>
+          <a:lstStyle/>
+          <a:p>
+            <a:pPr indent="0" marL="0">
+              <a:buNone/>
+            </a:pPr>
+            <a:r>
+              <a:rPr lang="en-US" sz="1800" b="1" dirty="0">
+                <a:solidFill>
+                  <a:srgbClr val="F4F6F5"/>
+                </a:solidFill>
+                <a:latin typeface="Manrope" pitchFamily="34" charset="0"/>
+                <a:ea typeface="Manrope" pitchFamily="34" charset="-122"/>
+                <a:cs typeface="Manrope" pitchFamily="34" charset="-120"/>
+              </a:rPr>
+              <a:t>+91 7356 333 965</a:t>
+            </a:r>
+            <a:endParaRPr lang="en-US" sz="1800" dirty="0"/>
+          </a:p>
+        </p:txBody>
+      </p:sp>
+      <p:sp>
+        <p:nvSpPr>
+          <p:cNvPr id="9" name="Text 6"/>
+          <p:cNvSpPr txBox="1"/>
+          <p:nvPr/>
+        </p:nvSpPr>
+        <p:spPr>
+          <a:xfrm>
+            <a:off x="685800" y="4764024"/>
+            <a:ext cx="1097280" cy="201168"/>
+          </a:xfrm>
+          <a:prstGeom prst="rect">
+            <a:avLst/>
+          </a:prstGeom>
+          <a:noFill/>
+          <a:ln/>
+        </p:spPr>
+        <p:txBody>
+          <a:bodyPr wrap="square" lIns="0" tIns="0" rIns="0" bIns="0" rtlCol="0" anchor="t"/>
+          <a:lstStyle/>
+          <a:p>
+            <a:pPr indent="0" marL="0">
+              <a:buNone/>
+            </a:pPr>
+            <a:r>
+              <a:rPr lang="en-US" sz="1000" b="1" spc="200" kern="0" dirty="0">
+                <a:solidFill>
+                  <a:srgbClr val="6B7773"/>
+                </a:solidFill>
+                <a:latin typeface="Plus Jakarta Sans" pitchFamily="34" charset="0"/>
+                <a:ea typeface="Plus Jakarta Sans" pitchFamily="34" charset="-122"/>
+                <a:cs typeface="Plus Jakarta Sans" pitchFamily="34" charset="-120"/>
+              </a:rPr>
+              <a:t>EMAIL</a:t>
+            </a:r>
+            <a:endParaRPr lang="en-US" sz="1000" dirty="0"/>
+          </a:p>
+        </p:txBody>
+      </p:sp>
+      <p:sp>
+        <p:nvSpPr>
+          <p:cNvPr id="10" name="Text 7"/>
+          <p:cNvSpPr txBox="1"/>
+          <p:nvPr/>
+        </p:nvSpPr>
+        <p:spPr>
+          <a:xfrm>
+            <a:off x="1874520" y="4709160"/>
+            <a:ext cx="4107028" cy="310896"/>
+          </a:xfrm>
+          <a:prstGeom prst="rect">
+            <a:avLst/>
+          </a:prstGeom>
+          <a:noFill/>
+          <a:ln/>
+        </p:spPr>
+        <p:txBody>
+          <a:bodyPr wrap="square" lIns="0" tIns="0" rIns="0" bIns="0" rtlCol="0" anchor="ctr"/>
+          <a:lstStyle/>
+          <a:p>
+            <a:pPr indent="0" marL="0">
+              <a:buNone/>
+            </a:pPr>
+            <a:r>
+              <a:rPr lang="en-US" sz="1800" b="1" dirty="0">
+                <a:solidFill>
+                  <a:srgbClr val="F4F6F5"/>
+                </a:solidFill>
+                <a:latin typeface="Manrope" pitchFamily="34" charset="0"/>
+                <a:ea typeface="Manrope" pitchFamily="34" charset="-122"/>
+                <a:cs typeface="Manrope" pitchFamily="34" charset="-120"/>
+              </a:rPr>
+              <a:t>info@storibodcreatives.com</a:t>
+            </a:r>
+            <a:endParaRPr lang="en-US" sz="1800" dirty="0"/>
+          </a:p>
+        </p:txBody>
+      </p:sp>
+      <p:sp>
+        <p:nvSpPr>
+          <p:cNvPr id="11" name="Text 8"/>
+          <p:cNvSpPr txBox="1"/>
+          <p:nvPr/>
+        </p:nvSpPr>
+        <p:spPr>
+          <a:xfrm>
+            <a:off x="685800" y="5221224"/>
+            <a:ext cx="1097280" cy="201168"/>
+          </a:xfrm>
+          <a:prstGeom prst="rect">
+            <a:avLst/>
+          </a:prstGeom>
+          <a:noFill/>
+          <a:ln/>
+        </p:spPr>
+        <p:txBody>
+          <a:bodyPr wrap="square" lIns="0" tIns="0" rIns="0" bIns="0" rtlCol="0" anchor="t"/>
+          <a:lstStyle/>
+          <a:p>
+            <a:pPr indent="0" marL="0">
+              <a:buNone/>
+            </a:pPr>
+            <a:r>
+              <a:rPr lang="en-US" sz="1000" b="1" spc="200" kern="0" dirty="0">
+                <a:solidFill>
+                  <a:srgbClr val="6B7773"/>
+                </a:solidFill>
+                <a:latin typeface="Plus Jakarta Sans" pitchFamily="34" charset="0"/>
+                <a:ea typeface="Plus Jakarta Sans" pitchFamily="34" charset="-122"/>
+                <a:cs typeface="Plus Jakarta Sans" pitchFamily="34" charset="-120"/>
+              </a:rPr>
+              <a:t>SOCIAL</a:t>
+            </a:r>
+            <a:endParaRPr lang="en-US" sz="1000" dirty="0"/>
+          </a:p>
+        </p:txBody>
+      </p:sp>
+      <p:sp>
+        <p:nvSpPr>
+          <p:cNvPr id="12" name="Text 9"/>
+          <p:cNvSpPr txBox="1"/>
+          <p:nvPr/>
+        </p:nvSpPr>
+        <p:spPr>
+          <a:xfrm>
+            <a:off x="1874520" y="5166360"/>
+            <a:ext cx="4107028" cy="310896"/>
+          </a:xfrm>
+          <a:prstGeom prst="rect">
+            <a:avLst/>
+          </a:prstGeom>
+          <a:noFill/>
+          <a:ln/>
+        </p:spPr>
+        <p:txBody>
+          <a:bodyPr wrap="square" lIns="0" tIns="0" rIns="0" bIns="0" rtlCol="0" anchor="ctr"/>
+          <a:lstStyle/>
+          <a:p>
+            <a:pPr indent="0" marL="0">
+              <a:buNone/>
+            </a:pPr>
+            <a:r>
+              <a:rPr lang="en-US" sz="1800" b="1" dirty="0">
+                <a:solidFill>
+                  <a:srgbClr val="F4F6F5"/>
+                </a:solidFill>
+                <a:latin typeface="Manrope" pitchFamily="34" charset="0"/>
+                <a:ea typeface="Manrope" pitchFamily="34" charset="-122"/>
+                <a:cs typeface="Manrope" pitchFamily="34" charset="-120"/>
+              </a:rPr>
+              <a:t>@bodstudio</a:t>
+            </a:r>
+            <a:endParaRPr lang="en-US" sz="1800" dirty="0"/>
+          </a:p>
+        </p:txBody>
+      </p:sp>
+      <p:pic>
+        <p:nvPicPr>
+          <p:cNvPr id="13" name="Image 1" descr="preencoded.png">    </p:cNvPr>
+          <p:cNvPicPr>
+            <a:picLocks noChangeAspect="1"/>
+          </p:cNvPicPr>
+          <p:nvPr/>
+        </p:nvPicPr>
+        <p:blipFill>
+          <a:blip r:embed="rId2"/>
+          <a:stretch>
+            <a:fillRect/>
+          </a:stretch>
+        </p:blipFill>
+        <p:spPr>
+          <a:xfrm>
+            <a:off x="685800" y="6245352"/>
+            <a:ext cx="365760" cy="365760"/>
+          </a:xfrm>
+          <a:prstGeom prst="rect">
+            <a:avLst/>
+          </a:prstGeom>
+        </p:spPr>
+      </p:pic>
+      <p:sp>
+        <p:nvSpPr>
+          <p:cNvPr id="14" name="Text 10"/>
+          <p:cNvSpPr txBox="1"/>
+          <p:nvPr/>
+        </p:nvSpPr>
+        <p:spPr>
+          <a:xfrm>
+            <a:off x="1188720" y="6355080"/>
+            <a:ext cx="3657600" cy="201168"/>
+          </a:xfrm>
+          <a:prstGeom prst="rect">
+            <a:avLst/>
+          </a:prstGeom>
+          <a:noFill/>
+          <a:ln/>
+        </p:spPr>
+        <p:txBody>
+          <a:bodyPr wrap="square" lIns="0" tIns="0" rIns="0" bIns="0" rtlCol="0" anchor="t"/>
+          <a:lstStyle/>
+          <a:p>
+            <a:pPr indent="0" marL="0">
+              <a:buNone/>
+            </a:pPr>
+            <a:r>
+              <a:rPr lang="en-US" sz="1000" b="1" spc="200" kern="0" dirty="0">
+                <a:solidFill>
+                  <a:srgbClr val="9AA7A2"/>
+                </a:solidFill>
+                <a:latin typeface="Plus Jakarta Sans" pitchFamily="34" charset="0"/>
+                <a:ea typeface="Plus Jakarta Sans" pitchFamily="34" charset="-122"/>
+                <a:cs typeface="Plus Jakarta Sans" pitchFamily="34" charset="-120"/>
+              </a:rPr>
+              <a:t>POWERED BY BOD STUDIO</a:t>
+            </a:r>
+            <a:endParaRPr lang="en-US" sz="1000" dirty="0"/>
+          </a:p>
+        </p:txBody>
+      </p:sp>
+      <p:pic>
+        <p:nvPicPr>
+          <p:cNvPr id="15" name="Image 2" descr="/tmp/claude-0/-home-user-Claude-Works/c609e3f7-e17f-5f43-8424-4df30cb9a6a9/scratchpad/build/s/img/m_angR_focus_light.png">    </p:cNvPr>
+          <p:cNvPicPr>
+            <a:picLocks noChangeAspect="1"/>
+          </p:cNvPicPr>
+          <p:nvPr/>
+        </p:nvPicPr>
+        <p:blipFill>
+          <a:blip r:embed="rId3"/>
+          <a:stretch>
+            <a:fillRect/>
+          </a:stretch>
+        </p:blipFill>
+        <p:spPr>
+          <a:xfrm>
+            <a:off x="8958496" y="640080"/>
+            <a:ext cx="2547400" cy="5577840"/>
+          </a:xfrm>
+          <a:prstGeom prst="rect">
+            <a:avLst/>
+          </a:prstGeom>
+        </p:spPr>
+      </p:pic>
+      <p:pic>
+        <p:nvPicPr>
+          <p:cNvPr id="16" name="Image 3" descr="/tmp/claude-0/-home-user-Claude-Works/c609e3f7-e17f-5f43-8424-4df30cb9a6a9/scratchpad/build/s/img/annan_waving.png">    </p:cNvPr>
+          <p:cNvPicPr>
+            <a:picLocks noChangeAspect="1"/>
+          </p:cNvPicPr>
+          <p:nvPr/>
+        </p:nvPicPr>
+        <p:blipFill>
+          <a:blip r:embed="rId4"/>
+          <a:stretch>
+            <a:fillRect/>
+          </a:stretch>
+        </p:blipFill>
+        <p:spPr>
+          <a:xfrm>
+            <a:off x="7008766" y="3931920"/>
+            <a:ext cx="2269769" cy="2286000"/>
+          </a:xfrm>
+          <a:prstGeom prst="rect">
+            <a:avLst/>
+          </a:prstGeom>
+        </p:spPr>
+      </p:pic>
+      <p:sp>
+        <p:nvSpPr>
+          <p:cNvPr id="17" name="Shape 11"/>
+          <p:cNvSpPr/>
+          <p:nvPr/>
+        </p:nvSpPr>
+        <p:spPr>
+          <a:xfrm>
+            <a:off x="7356026" y="2970428"/>
+            <a:ext cx="2167235" cy="795528"/>
+          </a:xfrm>
+          <a:prstGeom prst="roundRect">
+            <a:avLst>
+              <a:gd name="adj" fmla="val 20690"/>
+            </a:avLst>
+          </a:prstGeom>
+          <a:solidFill>
+            <a:srgbClr val="F4F6F5"/>
+          </a:solidFill>
+          <a:ln/>
+        </p:spPr>
+      </p:sp>
+      <p:sp>
+        <p:nvSpPr>
+          <p:cNvPr id="18" name="Shape 12"/>
+          <p:cNvSpPr/>
+          <p:nvPr/>
+        </p:nvSpPr>
+        <p:spPr>
+          <a:xfrm rot="10800000">
+            <a:off x="7778963" y="3756812"/>
+            <a:ext cx="237744" cy="182880"/>
+          </a:xfrm>
+          <a:prstGeom prst="triangle">
+            <a:avLst/>
+          </a:prstGeom>
+          <a:solidFill>
+            <a:srgbClr val="F4F6F5"/>
+          </a:solidFill>
+          <a:ln/>
+        </p:spPr>
+      </p:sp>
+      <p:sp>
+        <p:nvSpPr>
+          <p:cNvPr id="19" name="Text 13"/>
+          <p:cNvSpPr txBox="1"/>
+          <p:nvPr/>
+        </p:nvSpPr>
+        <p:spPr>
+          <a:xfrm>
+            <a:off x="7593770" y="3135020"/>
+            <a:ext cx="1691747" cy="466344"/>
+          </a:xfrm>
+          <a:prstGeom prst="rect">
+            <a:avLst/>
+          </a:prstGeom>
+          <a:noFill/>
+          <a:ln/>
+        </p:spPr>
+        <p:txBody>
+          <a:bodyPr wrap="square" lIns="0" tIns="0" rIns="0" bIns="0" rtlCol="0" anchor="ctr"/>
+          <a:lstStyle/>
+          <a:p>
+            <a:pPr indent="0" marL="0">
+              <a:lnSpc>
+                <a:spcPts val="1840"/>
+              </a:lnSpc>
+              <a:buNone/>
+            </a:pPr>
+            <a:r>
+              <a:rPr lang="en-US" sz="1500" b="1" dirty="0">
+                <a:solidFill>
+                  <a:srgbClr val="0B0D0C"/>
+                </a:solidFill>
+                <a:latin typeface="Manrope" pitchFamily="34" charset="0"/>
+                <a:ea typeface="Manrope" pitchFamily="34" charset="-122"/>
+                <a:cs typeface="Manrope" pitchFamily="34" charset="-120"/>
+              </a:rPr>
+              <a:t>Come by. I'll</a:t>
+            </a:r>
+            <a:endParaRPr lang="en-US" sz="1500" dirty="0"/>
+          </a:p>
+          <a:p>
+            <a:pPr indent="0" marL="0">
+              <a:lnSpc>
+                <a:spcPts val="1840"/>
+              </a:lnSpc>
+              <a:buNone/>
+            </a:pPr>
+            <a:r>
+              <a:rPr lang="en-US" sz="1500" b="1" dirty="0">
+                <a:solidFill>
+                  <a:srgbClr val="0B0D0C"/>
+                </a:solidFill>
+                <a:latin typeface="Manrope" pitchFamily="34" charset="0"/>
+                <a:ea typeface="Manrope" pitchFamily="34" charset="-122"/>
+                <a:cs typeface="Manrope" pitchFamily="34" charset="-120"/>
+              </a:rPr>
+              <a:t>show you around.</a:t>
+            </a:r>
+            <a:endParaRPr lang="en-US" sz="1500" dirty="0"/>
           </a:p>
         </p:txBody>
       </p:sp>

</xml_diff>

<commit_message>
Samples: apply lime pill speech bubbles (style B)
Co-Authored-By: Claude Opus 5.5 <noreply@anthropic.com>
Claude-Session: https://claude.ai/code/session_01GrK1EgoeNeSZw9mqcLcVqN
</commit_message>
<xml_diff>
--- a/bod-app-sales-deck/samples/Bod-App-Sample-Slides.pptx
+++ b/bod-app-sales-deck/samples/Bod-App-Sample-Slides.pptx
@@ -1436,58 +1436,40 @@
           </a:prstGeom>
         </p:spPr>
       </p:pic>
-      <p:sp>
-        <p:nvSpPr>
-          <p:cNvPr id="11" name="Shape 5"/>
-          <p:cNvSpPr/>
-          <p:nvPr/>
-        </p:nvSpPr>
-        <p:spPr>
-          <a:xfrm>
-            <a:off x="7159841" y="2793291"/>
-            <a:ext cx="2167235" cy="795528"/>
-          </a:xfrm>
-          <a:prstGeom prst="roundRect">
-            <a:avLst>
-              <a:gd name="adj" fmla="val 20690"/>
-            </a:avLst>
-          </a:prstGeom>
-          <a:solidFill>
-            <a:srgbClr val="F4F6F5"/>
-          </a:solidFill>
-          <a:ln/>
-        </p:spPr>
-      </p:sp>
-      <p:sp>
-        <p:nvSpPr>
-          <p:cNvPr id="12" name="Shape 6"/>
-          <p:cNvSpPr/>
-          <p:nvPr/>
-        </p:nvSpPr>
-        <p:spPr>
-          <a:xfrm rot="10800000">
-            <a:off x="7474416" y="3579675"/>
-            <a:ext cx="237744" cy="182880"/>
-          </a:xfrm>
-          <a:prstGeom prst="triangle">
-            <a:avLst/>
-          </a:prstGeom>
-          <a:solidFill>
-            <a:srgbClr val="F4F6F5"/>
-          </a:solidFill>
-          <a:ln/>
-        </p:spPr>
-      </p:sp>
-      <p:sp>
-        <p:nvSpPr>
-          <p:cNvPr id="13" name="Text 7"/>
-          <p:cNvSpPr txBox="1"/>
-          <p:nvPr/>
-        </p:nvSpPr>
-        <p:spPr>
-          <a:xfrm>
-            <a:off x="7397585" y="2957883"/>
-            <a:ext cx="1691747" cy="466344"/>
+      <p:pic>
+        <p:nvPicPr>
+          <p:cNvPr id="11" name="Image 4" descr="preencoded.png">    </p:cNvPr>
+          <p:cNvPicPr>
+            <a:picLocks noChangeAspect="1"/>
+          </p:cNvPicPr>
+          <p:nvPr/>
+        </p:nvPicPr>
+        <p:blipFill>
+          <a:blip r:embed="rId5"/>
+          <a:stretch>
+            <a:fillRect/>
+          </a:stretch>
+        </p:blipFill>
+        <p:spPr>
+          <a:xfrm>
+            <a:off x="7052861" y="2692707"/>
+            <a:ext cx="2340110" cy="1143000"/>
+          </a:xfrm>
+          <a:prstGeom prst="rect">
+            <a:avLst/>
+          </a:prstGeom>
+        </p:spPr>
+      </p:pic>
+      <p:sp>
+        <p:nvSpPr>
+          <p:cNvPr id="12" name="Text 5"/>
+          <p:cNvSpPr txBox="1"/>
+          <p:nvPr/>
+        </p:nvSpPr>
+        <p:spPr>
+          <a:xfrm>
+            <a:off x="7372901" y="2912163"/>
+            <a:ext cx="1718318" cy="466344"/>
           </a:xfrm>
           <a:prstGeom prst="rect">
             <a:avLst/>
@@ -1763,113 +1745,9 @@
           </a:prstGeom>
         </p:spPr>
       </p:pic>
-      <p:sp>
-        <p:nvSpPr>
-          <p:cNvPr id="7" name="Shape 3"/>
-          <p:cNvSpPr/>
-          <p:nvPr/>
-        </p:nvSpPr>
-        <p:spPr>
-          <a:xfrm>
-            <a:off x="368752" y="3456121"/>
-            <a:ext cx="2814816" cy="795528"/>
-          </a:xfrm>
-          <a:prstGeom prst="roundRect">
-            <a:avLst>
-              <a:gd name="adj" fmla="val 20690"/>
-            </a:avLst>
-          </a:prstGeom>
-          <a:solidFill>
-            <a:srgbClr val="F4F6F5"/>
-          </a:solidFill>
-          <a:ln/>
-        </p:spPr>
-      </p:sp>
-      <p:sp>
-        <p:nvSpPr>
-          <p:cNvPr id="8" name="Shape 4"/>
-          <p:cNvSpPr/>
-          <p:nvPr/>
-        </p:nvSpPr>
-        <p:spPr>
-          <a:xfrm rot="10800000">
-            <a:off x="1150621" y="4242505"/>
-            <a:ext cx="237744" cy="182880"/>
-          </a:xfrm>
-          <a:prstGeom prst="triangle">
-            <a:avLst/>
-          </a:prstGeom>
-          <a:solidFill>
-            <a:srgbClr val="F4F6F5"/>
-          </a:solidFill>
-          <a:ln/>
-        </p:spPr>
-      </p:sp>
-      <p:sp>
-        <p:nvSpPr>
-          <p:cNvPr id="9" name="Text 5"/>
-          <p:cNvSpPr txBox="1"/>
-          <p:nvPr/>
-        </p:nvSpPr>
-        <p:spPr>
-          <a:xfrm>
-            <a:off x="606496" y="3620713"/>
-            <a:ext cx="2339328" cy="466344"/>
-          </a:xfrm>
-          <a:prstGeom prst="rect">
-            <a:avLst/>
-          </a:prstGeom>
-          <a:noFill/>
-          <a:ln/>
-        </p:spPr>
-        <p:txBody>
-          <a:bodyPr wrap="square" lIns="0" tIns="0" rIns="0" bIns="0" rtlCol="0" anchor="ctr"/>
-          <a:lstStyle/>
-          <a:p>
-            <a:pPr indent="0" marL="0">
-              <a:lnSpc>
-                <a:spcPts val="1840"/>
-              </a:lnSpc>
-              <a:buNone/>
-            </a:pPr>
-            <a:r>
-              <a:rPr lang="en-US" sz="1500" b="1" dirty="0">
-                <a:solidFill>
-                  <a:srgbClr val="0B0D0C"/>
-                </a:solidFill>
-                <a:latin typeface="Manrope" pitchFamily="34" charset="0"/>
-                <a:ea typeface="Manrope" pitchFamily="34" charset="-122"/>
-                <a:cs typeface="Manrope" pitchFamily="34" charset="-120"/>
-              </a:rPr>
-              <a:t>No reply yet? I've written</a:t>
-            </a:r>
-            <a:endParaRPr lang="en-US" sz="1500" dirty="0"/>
-          </a:p>
-          <a:p>
-            <a:pPr indent="0" marL="0">
-              <a:lnSpc>
-                <a:spcPts val="1840"/>
-              </a:lnSpc>
-              <a:buNone/>
-            </a:pPr>
-            <a:r>
-              <a:rPr lang="en-US" sz="1500" b="1" dirty="0">
-                <a:solidFill>
-                  <a:srgbClr val="0B0D0C"/>
-                </a:solidFill>
-                <a:latin typeface="Manrope" pitchFamily="34" charset="0"/>
-                <a:ea typeface="Manrope" pitchFamily="34" charset="-122"/>
-                <a:cs typeface="Manrope" pitchFamily="34" charset="-120"/>
-              </a:rPr>
-              <a:t>the follow-up for you.</a:t>
-            </a:r>
-            <a:endParaRPr lang="en-US" sz="1500" dirty="0"/>
-          </a:p>
-        </p:txBody>
-      </p:sp>
       <p:pic>
         <p:nvPicPr>
-          <p:cNvPr id="10" name="Image 2" descr="/tmp/claude-0/-home-user-Claude-Works/c609e3f7-e17f-5f43-8424-4df30cb9a6a9/scratchpad/build/s/img/m_front_nudge_light.png">    </p:cNvPr>
+          <p:cNvPr id="7" name="Image 2" descr="preencoded.png">    </p:cNvPr>
           <p:cNvPicPr>
             <a:picLocks noChangeAspect="1"/>
           </p:cNvPicPr>
@@ -1883,17 +1761,79 @@
         </p:blipFill>
         <p:spPr>
           <a:xfrm>
-            <a:off x="9163669" y="1325880"/>
-            <a:ext cx="2342226" cy="4846320"/>
+            <a:off x="348802" y="3355537"/>
+            <a:ext cx="3008011" cy="1143000"/>
           </a:xfrm>
           <a:prstGeom prst="rect">
             <a:avLst/>
           </a:prstGeom>
         </p:spPr>
       </p:pic>
+      <p:sp>
+        <p:nvSpPr>
+          <p:cNvPr id="8" name="Text 3"/>
+          <p:cNvSpPr txBox="1"/>
+          <p:nvPr/>
+        </p:nvSpPr>
+        <p:spPr>
+          <a:xfrm>
+            <a:off x="668842" y="3574993"/>
+            <a:ext cx="2386219" cy="466344"/>
+          </a:xfrm>
+          <a:prstGeom prst="rect">
+            <a:avLst/>
+          </a:prstGeom>
+          <a:noFill/>
+          <a:ln/>
+        </p:spPr>
+        <p:txBody>
+          <a:bodyPr wrap="square" lIns="0" tIns="0" rIns="0" bIns="0" rtlCol="0" anchor="ctr"/>
+          <a:lstStyle/>
+          <a:p>
+            <a:pPr indent="0" marL="0">
+              <a:lnSpc>
+                <a:spcPts val="1840"/>
+              </a:lnSpc>
+              <a:buNone/>
+            </a:pPr>
+            <a:r>
+              <a:rPr lang="en-US" sz="1500" b="1" dirty="0">
+                <a:solidFill>
+                  <a:srgbClr val="0B0D0C"/>
+                </a:solidFill>
+                <a:latin typeface="Manrope" pitchFamily="34" charset="0"/>
+                <a:ea typeface="Manrope" pitchFamily="34" charset="-122"/>
+                <a:cs typeface="Manrope" pitchFamily="34" charset="-120"/>
+              </a:rPr>
+              <a:t>No reply yet? I've written</a:t>
+            </a:r>
+            <a:endParaRPr lang="en-US" sz="1500" dirty="0"/>
+          </a:p>
+          <a:p>
+            <a:pPr indent="0" marL="0">
+              <a:lnSpc>
+                <a:spcPts val="1840"/>
+              </a:lnSpc>
+              <a:buNone/>
+            </a:pPr>
+            <a:r>
+              <a:rPr lang="en-US" sz="1500" b="1" dirty="0">
+                <a:solidFill>
+                  <a:srgbClr val="0B0D0C"/>
+                </a:solidFill>
+                <a:latin typeface="Manrope" pitchFamily="34" charset="0"/>
+                <a:ea typeface="Manrope" pitchFamily="34" charset="-122"/>
+                <a:cs typeface="Manrope" pitchFamily="34" charset="-120"/>
+              </a:rPr>
+              <a:t>the follow-up for you.</a:t>
+            </a:r>
+            <a:endParaRPr lang="en-US" sz="1500" dirty="0"/>
+          </a:p>
+        </p:txBody>
+      </p:sp>
       <p:pic>
         <p:nvPicPr>
-          <p:cNvPr id="11" name="Image 3" descr="/tmp/claude-0/-home-user-Claude-Works/c609e3f7-e17f-5f43-8424-4df30cb9a6a9/scratchpad/build/s/img/m_front_nudge_dark.png">    </p:cNvPr>
+          <p:cNvPr id="9" name="Image 3" descr="/tmp/claude-0/-home-user-Claude-Works/c609e3f7-e17f-5f43-8424-4df30cb9a6a9/scratchpad/build/s/img/m_front_nudge_light.png">    </p:cNvPr>
           <p:cNvPicPr>
             <a:picLocks noChangeAspect="1"/>
           </p:cNvPicPr>
@@ -1907,6 +1847,30 @@
         </p:blipFill>
         <p:spPr>
           <a:xfrm>
+            <a:off x="9163669" y="1325880"/>
+            <a:ext cx="2342226" cy="4846320"/>
+          </a:xfrm>
+          <a:prstGeom prst="rect">
+            <a:avLst/>
+          </a:prstGeom>
+        </p:spPr>
+      </p:pic>
+      <p:pic>
+        <p:nvPicPr>
+          <p:cNvPr id="10" name="Image 4" descr="/tmp/claude-0/-home-user-Claude-Works/c609e3f7-e17f-5f43-8424-4df30cb9a6a9/scratchpad/build/s/img/m_front_nudge_dark.png">    </p:cNvPr>
+          <p:cNvPicPr>
+            <a:picLocks noChangeAspect="1"/>
+          </p:cNvPicPr>
+          <p:nvPr/>
+        </p:nvPicPr>
+        <p:blipFill>
+          <a:blip r:embed="rId5"/>
+          <a:stretch>
+            <a:fillRect/>
+          </a:stretch>
+        </p:blipFill>
+        <p:spPr>
+          <a:xfrm>
             <a:off x="7130872" y="685800"/>
             <a:ext cx="2651577" cy="5486400"/>
           </a:xfrm>
@@ -1917,7 +1881,7 @@
       </p:pic>
       <p:sp>
         <p:nvSpPr>
-          <p:cNvPr id="12" name="Text 6"/>
+          <p:cNvPr id="11" name="Text 4"/>
           <p:cNvSpPr txBox="1"/>
           <p:nvPr/>
         </p:nvSpPr>
@@ -1956,7 +1920,7 @@
       </p:sp>
       <p:sp>
         <p:nvSpPr>
-          <p:cNvPr id="13" name="Text 7"/>
+          <p:cNvPr id="12" name="Text 5"/>
           <p:cNvSpPr txBox="1"/>
           <p:nvPr/>
         </p:nvSpPr>
@@ -1995,7 +1959,7 @@
       </p:sp>
       <p:sp>
         <p:nvSpPr>
-          <p:cNvPr id="14" name="Text 8"/>
+          <p:cNvPr id="13" name="Text 6"/>
           <p:cNvSpPr txBox="1"/>
           <p:nvPr/>
         </p:nvSpPr>
@@ -2189,7 +2153,7 @@
         </p:nvSpPr>
         <p:spPr>
           <a:xfrm>
-            <a:off x="1554480" y="3223260"/>
+            <a:off x="1554480" y="3543300"/>
             <a:ext cx="8912108" cy="0"/>
           </a:xfrm>
           <a:prstGeom prst="line">
@@ -2212,7 +2176,7 @@
         </p:nvSpPr>
         <p:spPr>
           <a:xfrm>
-            <a:off x="685800" y="2788920"/>
+            <a:off x="685800" y="3108960"/>
             <a:ext cx="868680" cy="868680"/>
           </a:xfrm>
           <a:prstGeom prst="ellipse">
@@ -2245,7 +2209,7 @@
         </p:blipFill>
         <p:spPr>
           <a:xfrm>
-            <a:off x="929030" y="3032150"/>
+            <a:off x="929030" y="3352190"/>
             <a:ext cx="382219" cy="382219"/>
           </a:xfrm>
           <a:prstGeom prst="rect">
@@ -2261,7 +2225,7 @@
         </p:nvSpPr>
         <p:spPr>
           <a:xfrm>
-            <a:off x="685800" y="3977640"/>
+            <a:off x="685800" y="4297680"/>
             <a:ext cx="1907987" cy="201168"/>
           </a:xfrm>
           <a:prstGeom prst="rect">
@@ -2300,7 +2264,7 @@
         </p:nvSpPr>
         <p:spPr>
           <a:xfrm>
-            <a:off x="685800" y="4251960"/>
+            <a:off x="685800" y="4572000"/>
             <a:ext cx="1907987" cy="731520"/>
           </a:xfrm>
           <a:prstGeom prst="rect">
@@ -2342,7 +2306,7 @@
         </p:nvSpPr>
         <p:spPr>
           <a:xfrm>
-            <a:off x="685800" y="5074920"/>
+            <a:off x="685800" y="5394960"/>
             <a:ext cx="1907987" cy="640080"/>
           </a:xfrm>
           <a:prstGeom prst="rect">
@@ -2384,7 +2348,7 @@
         </p:nvSpPr>
         <p:spPr>
           <a:xfrm>
-            <a:off x="2913827" y="2788920"/>
+            <a:off x="2913827" y="3108960"/>
             <a:ext cx="868680" cy="868680"/>
           </a:xfrm>
           <a:prstGeom prst="ellipse">
@@ -2417,7 +2381,7 @@
         </p:blipFill>
         <p:spPr>
           <a:xfrm>
-            <a:off x="3157057" y="3032150"/>
+            <a:off x="3157057" y="3352190"/>
             <a:ext cx="382219" cy="382219"/>
           </a:xfrm>
           <a:prstGeom prst="rect">
@@ -2433,7 +2397,7 @@
         </p:nvSpPr>
         <p:spPr>
           <a:xfrm>
-            <a:off x="2913827" y="3977640"/>
+            <a:off x="2913827" y="4297680"/>
             <a:ext cx="1907987" cy="201168"/>
           </a:xfrm>
           <a:prstGeom prst="rect">
@@ -2472,7 +2436,7 @@
         </p:nvSpPr>
         <p:spPr>
           <a:xfrm>
-            <a:off x="2913827" y="4251960"/>
+            <a:off x="2913827" y="4572000"/>
             <a:ext cx="1907987" cy="731520"/>
           </a:xfrm>
           <a:prstGeom prst="rect">
@@ -2514,7 +2478,7 @@
         </p:nvSpPr>
         <p:spPr>
           <a:xfrm>
-            <a:off x="2913827" y="5074920"/>
+            <a:off x="2913827" y="5394960"/>
             <a:ext cx="1907987" cy="640080"/>
           </a:xfrm>
           <a:prstGeom prst="rect">
@@ -2556,7 +2520,7 @@
         </p:nvSpPr>
         <p:spPr>
           <a:xfrm>
-            <a:off x="5141854" y="2788920"/>
+            <a:off x="5141854" y="3108960"/>
             <a:ext cx="868680" cy="868680"/>
           </a:xfrm>
           <a:prstGeom prst="ellipse">
@@ -2589,7 +2553,7 @@
         </p:blipFill>
         <p:spPr>
           <a:xfrm>
-            <a:off x="5385084" y="3032150"/>
+            <a:off x="5385084" y="3352190"/>
             <a:ext cx="382219" cy="382219"/>
           </a:xfrm>
           <a:prstGeom prst="rect">
@@ -2605,7 +2569,7 @@
         </p:nvSpPr>
         <p:spPr>
           <a:xfrm>
-            <a:off x="5141854" y="3977640"/>
+            <a:off x="5141854" y="4297680"/>
             <a:ext cx="1907987" cy="201168"/>
           </a:xfrm>
           <a:prstGeom prst="rect">
@@ -2644,7 +2608,7 @@
         </p:nvSpPr>
         <p:spPr>
           <a:xfrm>
-            <a:off x="5141854" y="4251960"/>
+            <a:off x="5141854" y="4572000"/>
             <a:ext cx="1907987" cy="731520"/>
           </a:xfrm>
           <a:prstGeom prst="rect">
@@ -2686,7 +2650,7 @@
         </p:nvSpPr>
         <p:spPr>
           <a:xfrm>
-            <a:off x="5141854" y="5074920"/>
+            <a:off x="5141854" y="5394960"/>
             <a:ext cx="1907987" cy="640080"/>
           </a:xfrm>
           <a:prstGeom prst="rect">
@@ -2728,7 +2692,7 @@
         </p:nvSpPr>
         <p:spPr>
           <a:xfrm>
-            <a:off x="7369881" y="2788920"/>
+            <a:off x="7369881" y="3108960"/>
             <a:ext cx="868680" cy="868680"/>
           </a:xfrm>
           <a:prstGeom prst="ellipse">
@@ -2761,7 +2725,7 @@
         </p:blipFill>
         <p:spPr>
           <a:xfrm>
-            <a:off x="7613112" y="3032150"/>
+            <a:off x="7613112" y="3352190"/>
             <a:ext cx="382219" cy="382219"/>
           </a:xfrm>
           <a:prstGeom prst="rect">
@@ -2777,7 +2741,7 @@
         </p:nvSpPr>
         <p:spPr>
           <a:xfrm>
-            <a:off x="7369881" y="3977640"/>
+            <a:off x="7369881" y="4297680"/>
             <a:ext cx="1907987" cy="201168"/>
           </a:xfrm>
           <a:prstGeom prst="rect">
@@ -2816,7 +2780,7 @@
         </p:nvSpPr>
         <p:spPr>
           <a:xfrm>
-            <a:off x="7369881" y="4251960"/>
+            <a:off x="7369881" y="4572000"/>
             <a:ext cx="1907987" cy="731520"/>
           </a:xfrm>
           <a:prstGeom prst="rect">
@@ -2858,7 +2822,7 @@
         </p:nvSpPr>
         <p:spPr>
           <a:xfrm>
-            <a:off x="7369881" y="5074920"/>
+            <a:off x="7369881" y="5394960"/>
             <a:ext cx="1907987" cy="640080"/>
           </a:xfrm>
           <a:prstGeom prst="rect">
@@ -2900,7 +2864,7 @@
         </p:nvSpPr>
         <p:spPr>
           <a:xfrm>
-            <a:off x="9597908" y="2788920"/>
+            <a:off x="9597908" y="3108960"/>
             <a:ext cx="868680" cy="868680"/>
           </a:xfrm>
           <a:prstGeom prst="ellipse">
@@ -2933,7 +2897,7 @@
         </p:blipFill>
         <p:spPr>
           <a:xfrm>
-            <a:off x="9841139" y="3032150"/>
+            <a:off x="9841139" y="3352190"/>
             <a:ext cx="382219" cy="382219"/>
           </a:xfrm>
           <a:prstGeom prst="rect">
@@ -2949,7 +2913,7 @@
         </p:nvSpPr>
         <p:spPr>
           <a:xfrm>
-            <a:off x="9597908" y="3977640"/>
+            <a:off x="9597908" y="4297680"/>
             <a:ext cx="1907987" cy="201168"/>
           </a:xfrm>
           <a:prstGeom prst="rect">
@@ -2988,7 +2952,7 @@
         </p:nvSpPr>
         <p:spPr>
           <a:xfrm>
-            <a:off x="9597908" y="4251960"/>
+            <a:off x="9597908" y="4572000"/>
             <a:ext cx="1907987" cy="731520"/>
           </a:xfrm>
           <a:prstGeom prst="rect">
@@ -3030,7 +2994,7 @@
         </p:nvSpPr>
         <p:spPr>
           <a:xfrm>
-            <a:off x="9597908" y="5074920"/>
+            <a:off x="9597908" y="5394960"/>
             <a:ext cx="1907987" cy="640080"/>
           </a:xfrm>
           <a:prstGeom prst="rect">
@@ -3080,66 +3044,48 @@
         </p:blipFill>
         <p:spPr>
           <a:xfrm>
-            <a:off x="10134419" y="548640"/>
-            <a:ext cx="1481205" cy="1783080"/>
+            <a:off x="10457947" y="1572768"/>
+            <a:ext cx="1139388" cy="1371600"/>
           </a:xfrm>
           <a:prstGeom prst="rect">
             <a:avLst/>
           </a:prstGeom>
         </p:spPr>
       </p:pic>
-      <p:sp>
-        <p:nvSpPr>
-          <p:cNvPr id="32" name="Shape 24"/>
-          <p:cNvSpPr/>
-          <p:nvPr/>
-        </p:nvSpPr>
-        <p:spPr>
-          <a:xfrm>
-            <a:off x="7580991" y="803483"/>
-            <a:ext cx="2497872" cy="795528"/>
-          </a:xfrm>
-          <a:prstGeom prst="roundRect">
-            <a:avLst>
-              <a:gd name="adj" fmla="val 20690"/>
-            </a:avLst>
-          </a:prstGeom>
-          <a:solidFill>
-            <a:srgbClr val="F4F6F5"/>
-          </a:solidFill>
-          <a:ln/>
-        </p:spPr>
-      </p:sp>
-      <p:sp>
-        <p:nvSpPr>
-          <p:cNvPr id="33" name="Shape 25"/>
-          <p:cNvSpPr/>
-          <p:nvPr/>
-        </p:nvSpPr>
-        <p:spPr>
-          <a:xfrm rot="5400000">
-            <a:off x="10042287" y="1082375"/>
-            <a:ext cx="237744" cy="182880"/>
-          </a:xfrm>
-          <a:prstGeom prst="triangle">
-            <a:avLst/>
-          </a:prstGeom>
-          <a:solidFill>
-            <a:srgbClr val="F4F6F5"/>
-          </a:solidFill>
-          <a:ln/>
-        </p:spPr>
-      </p:sp>
-      <p:sp>
-        <p:nvSpPr>
-          <p:cNvPr id="34" name="Text 26"/>
-          <p:cNvSpPr txBox="1"/>
-          <p:nvPr/>
-        </p:nvSpPr>
-        <p:spPr>
-          <a:xfrm>
-            <a:off x="7818735" y="968075"/>
-            <a:ext cx="2022384" cy="466344"/>
+      <p:pic>
+        <p:nvPicPr>
+          <p:cNvPr id="32" name="Image 6" descr="preencoded.png">    </p:cNvPr>
+          <p:cNvPicPr>
+            <a:picLocks noChangeAspect="1"/>
+          </p:cNvPicPr>
+          <p:nvPr/>
+        </p:nvPicPr>
+        <p:blipFill>
+          <a:blip r:embed="rId7"/>
+          <a:stretch>
+            <a:fillRect/>
+          </a:stretch>
+        </p:blipFill>
+        <p:spPr>
+          <a:xfrm>
+            <a:off x="8194918" y="481980"/>
+            <a:ext cx="2741501" cy="1143000"/>
+          </a:xfrm>
+          <a:prstGeom prst="rect">
+            <a:avLst/>
+          </a:prstGeom>
+        </p:spPr>
+      </p:pic>
+      <p:sp>
+        <p:nvSpPr>
+          <p:cNvPr id="33" name="Text 24"/>
+          <p:cNvSpPr txBox="1"/>
+          <p:nvPr/>
+        </p:nvSpPr>
+        <p:spPr>
+          <a:xfrm>
+            <a:off x="8514958" y="701436"/>
+            <a:ext cx="2055701" cy="466344"/>
           </a:xfrm>
           <a:prstGeom prst="rect">
             <a:avLst/>
@@ -3194,7 +3140,7 @@
       </p:sp>
       <p:sp>
         <p:nvSpPr>
-          <p:cNvPr id="35" name="Text 27"/>
+          <p:cNvPr id="34" name="Text 25"/>
           <p:cNvSpPr txBox="1"/>
           <p:nvPr/>
         </p:nvSpPr>
@@ -3233,7 +3179,7 @@
       </p:sp>
       <p:sp>
         <p:nvSpPr>
-          <p:cNvPr id="36" name="Text 28"/>
+          <p:cNvPr id="35" name="Text 26"/>
           <p:cNvSpPr txBox="1"/>
           <p:nvPr/>
         </p:nvSpPr>
@@ -3850,58 +3796,40 @@
           </a:prstGeom>
         </p:spPr>
       </p:pic>
-      <p:sp>
-        <p:nvSpPr>
-          <p:cNvPr id="17" name="Shape 11"/>
-          <p:cNvSpPr/>
-          <p:nvPr/>
-        </p:nvSpPr>
-        <p:spPr>
-          <a:xfrm>
-            <a:off x="7356026" y="2970428"/>
-            <a:ext cx="2167235" cy="795528"/>
-          </a:xfrm>
-          <a:prstGeom prst="roundRect">
-            <a:avLst>
-              <a:gd name="adj" fmla="val 20690"/>
-            </a:avLst>
-          </a:prstGeom>
-          <a:solidFill>
-            <a:srgbClr val="F4F6F5"/>
-          </a:solidFill>
-          <a:ln/>
-        </p:spPr>
-      </p:sp>
-      <p:sp>
-        <p:nvSpPr>
-          <p:cNvPr id="18" name="Shape 12"/>
-          <p:cNvSpPr/>
-          <p:nvPr/>
-        </p:nvSpPr>
-        <p:spPr>
-          <a:xfrm rot="10800000">
-            <a:off x="7778963" y="3756812"/>
-            <a:ext cx="237744" cy="182880"/>
-          </a:xfrm>
-          <a:prstGeom prst="triangle">
-            <a:avLst/>
-          </a:prstGeom>
-          <a:solidFill>
-            <a:srgbClr val="F4F6F5"/>
-          </a:solidFill>
-          <a:ln/>
-        </p:spPr>
-      </p:sp>
-      <p:sp>
-        <p:nvSpPr>
-          <p:cNvPr id="19" name="Text 13"/>
-          <p:cNvSpPr txBox="1"/>
-          <p:nvPr/>
-        </p:nvSpPr>
-        <p:spPr>
-          <a:xfrm>
-            <a:off x="7593770" y="3135020"/>
-            <a:ext cx="1691747" cy="466344"/>
+      <p:pic>
+        <p:nvPicPr>
+          <p:cNvPr id="17" name="Image 4" descr="preencoded.png">    </p:cNvPr>
+          <p:cNvPicPr>
+            <a:picLocks noChangeAspect="1"/>
+          </p:cNvPicPr>
+          <p:nvPr/>
+        </p:nvPicPr>
+        <p:blipFill>
+          <a:blip r:embed="rId5"/>
+          <a:stretch>
+            <a:fillRect/>
+          </a:stretch>
+        </p:blipFill>
+        <p:spPr>
+          <a:xfrm>
+            <a:off x="7289947" y="2869844"/>
+            <a:ext cx="2340110" cy="1143000"/>
+          </a:xfrm>
+          <a:prstGeom prst="rect">
+            <a:avLst/>
+          </a:prstGeom>
+        </p:spPr>
+      </p:pic>
+      <p:sp>
+        <p:nvSpPr>
+          <p:cNvPr id="18" name="Text 11"/>
+          <p:cNvSpPr txBox="1"/>
+          <p:nvPr/>
+        </p:nvSpPr>
+        <p:spPr>
+          <a:xfrm>
+            <a:off x="7609987" y="3089300"/>
+            <a:ext cx="1718318" cy="466344"/>
           </a:xfrm>
           <a:prstGeom prst="rect">
             <a:avLst/>

</xml_diff>